<commit_message>
Preenche os nomes e as matriculas dos dois alunos
Gabriel Henrique R. Macedo (07237) e Diego Soares Carvalho (07225), na capa
dos slides e no comentario do gerar_zip.sh. A divisao de tarefas, que o
template pede no slide de Modelagem, ficou na ultima linha do slide 3.

Com isso o R03 deixa de ser pendencia e o pacote de entrega sai como
TP1GabrielHenriqueRMacedo07237DiegoSoaresCarvalho07225.zip: os nomes vao sem
o ponto do "R." e sem espacos, porque a especificacao pede o formato
TP1Aluno1Matricula1Aluno2Matricula2.

Conferido de ponta a ponta: o zip monta com esse nome, compila do zero com
gcc e com make sem avisos, e roda o exemplo com o relatorio identico ao
esperado.

Co-Authored-By: Claude Opus 5 <noreply@anthropic.com>
</commit_message>
<xml_diff>
--- a/apresentacao/slides.pptx
+++ b/apresentacao/slides.pptx
@@ -8349,12 +8349,12 @@
           </a:p>
           <a:p>
             <a:r>
-              <a:t>&lt;Aluno 1&gt; – &lt;matrícula&gt;</a:t>
+              <a:t>Gabriel Henrique R. Macedo – 07237</a:t>
             </a:r>
           </a:p>
           <a:p>
             <a:r>
-              <a:t>&lt;Aluno 2&gt; – &lt;matrícula&gt;</a:t>
+              <a:t>Diego Soares Carvalho – 07225</a:t>
             </a:r>
           </a:p>
         </p:txBody>
@@ -9211,7 +9211,7 @@
               <a:buChar char="•"/>
             </a:pPr>
             <a:r>
-              <a:rPr sz="2400" b="0">
+              <a:rPr sz="2200" b="0">
                 <a:solidFill>
                   <a:srgbClr val="222320"/>
                 </a:solidFill>
@@ -9231,7 +9231,7 @@
               <a:buNone/>
             </a:pPr>
             <a:r>
-              <a:rPr sz="2400" b="1">
+              <a:rPr sz="2200" b="1">
                 <a:solidFill>
                   <a:srgbClr val="222320"/>
                 </a:solidFill>
@@ -9252,7 +9252,7 @@
               <a:buChar char="•"/>
             </a:pPr>
             <a:r>
-              <a:rPr sz="2400" b="0">
+              <a:rPr sz="2200" b="0">
                 <a:solidFill>
                   <a:srgbClr val="222320"/>
                 </a:solidFill>
@@ -9273,7 +9273,7 @@
               <a:buChar char="•"/>
             </a:pPr>
             <a:r>
-              <a:rPr sz="2400" b="0">
+              <a:rPr sz="2200" b="0">
                 <a:solidFill>
                   <a:srgbClr val="222320"/>
                 </a:solidFill>
@@ -9294,7 +9294,7 @@
               <a:buChar char="•"/>
             </a:pPr>
             <a:r>
-              <a:rPr sz="2400" b="0">
+              <a:rPr sz="2200" b="0">
                 <a:solidFill>
                   <a:srgbClr val="222320"/>
                 </a:solidFill>
@@ -9315,13 +9315,13 @@
               <a:buChar char="•"/>
             </a:pPr>
             <a:r>
-              <a:rPr sz="2400" b="0">
+              <a:rPr sz="2200" b="0">
                 <a:solidFill>
                   <a:srgbClr val="222320"/>
                 </a:solidFill>
                 <a:latin typeface="Lato"/>
               </a:rPr>
-              <a:t>&lt;Aluno 1&gt; ficou com &lt;...&gt; e &lt;Aluno 2&gt; com &lt;...&gt;.</a:t>
+              <a:t>Escrevemos o código juntos, um digitando e o outro revisando, alternando a cada módulo — foi o que manteve os dois sabendo explicar o projeto inteiro.</a:t>
             </a:r>
           </a:p>
         </p:txBody>

</xml_diff>